<commit_message>
feat: automate crypto research with public sources and vesting data
</commit_message>
<xml_diff>
--- a/crypto-project-assistant/presentation/Cryptoscope_Weeks_04_15_Local_AI.pptx
+++ b/crypto-project-assistant/presentation/Cryptoscope_Weeks_04_15_Local_AI.pptx
@@ -2,28 +2,28 @@
 <file path=ppt/presentation.xml><?xml version="1.0" encoding="utf-8"?>
 <p:presentation xmlns:p="http://schemas.openxmlformats.org/presentationml/2006/main">
   <p:sldMasterIdLst>
-    <p:sldMasterId xmlns:r="http://schemas.openxmlformats.org/officeDocument/2006/relationships" id="2147483648" r:id="Rb551905ee5b74b38"/>
+    <p:sldMasterId xmlns:r="http://schemas.openxmlformats.org/officeDocument/2006/relationships" id="2147483648" r:id="R74608d7a9b574e20"/>
   </p:sldMasterIdLst>
   <p:notesMasterIdLst>
-    <p:notesMasterId xmlns:r="http://schemas.openxmlformats.org/officeDocument/2006/relationships" r:id="Recbb91b3144749cb"/>
+    <p:notesMasterId xmlns:r="http://schemas.openxmlformats.org/officeDocument/2006/relationships" r:id="Ra0603b75561f4d85"/>
   </p:notesMasterIdLst>
   <p:sldIdLst>
-    <p:sldId xmlns:r="http://schemas.openxmlformats.org/officeDocument/2006/relationships" id="256" r:id="R81274548d6ca498c"/>
-    <p:sldId xmlns:r="http://schemas.openxmlformats.org/officeDocument/2006/relationships" id="257" r:id="R40c81a3fa5fa469a"/>
-    <p:sldId xmlns:r="http://schemas.openxmlformats.org/officeDocument/2006/relationships" id="258" r:id="Reb4b4d0d18ad4bfa"/>
-    <p:sldId xmlns:r="http://schemas.openxmlformats.org/officeDocument/2006/relationships" id="259" r:id="R85b7248748504677"/>
-    <p:sldId xmlns:r="http://schemas.openxmlformats.org/officeDocument/2006/relationships" id="260" r:id="R17b95f4b9423435e"/>
-    <p:sldId xmlns:r="http://schemas.openxmlformats.org/officeDocument/2006/relationships" id="261" r:id="Rbf75db0b2fa049a4"/>
-    <p:sldId xmlns:r="http://schemas.openxmlformats.org/officeDocument/2006/relationships" id="262" r:id="R4b45a86298304b1e"/>
-    <p:sldId xmlns:r="http://schemas.openxmlformats.org/officeDocument/2006/relationships" id="263" r:id="Rc1d5ac9557f64037"/>
-    <p:sldId xmlns:r="http://schemas.openxmlformats.org/officeDocument/2006/relationships" id="264" r:id="Rd0a7648e48e84c03"/>
-    <p:sldId xmlns:r="http://schemas.openxmlformats.org/officeDocument/2006/relationships" id="265" r:id="R7417496ee84a4e28"/>
-    <p:sldId xmlns:r="http://schemas.openxmlformats.org/officeDocument/2006/relationships" id="266" r:id="R615c9521ff3341de"/>
-    <p:sldId xmlns:r="http://schemas.openxmlformats.org/officeDocument/2006/relationships" id="267" r:id="R7d27253ae3a648c7"/>
-    <p:sldId xmlns:r="http://schemas.openxmlformats.org/officeDocument/2006/relationships" id="268" r:id="R50eb81be19b0482f"/>
-    <p:sldId xmlns:r="http://schemas.openxmlformats.org/officeDocument/2006/relationships" id="269" r:id="R82093e7473584949"/>
-    <p:sldId xmlns:r="http://schemas.openxmlformats.org/officeDocument/2006/relationships" id="270" r:id="Rf744fde8a72847fa"/>
-    <p:sldId xmlns:r="http://schemas.openxmlformats.org/officeDocument/2006/relationships" id="271" r:id="Rdf005b936ee84598"/>
+    <p:sldId xmlns:r="http://schemas.openxmlformats.org/officeDocument/2006/relationships" id="256" r:id="R5a840510afd94ea6"/>
+    <p:sldId xmlns:r="http://schemas.openxmlformats.org/officeDocument/2006/relationships" id="257" r:id="Rc83af2a569754f36"/>
+    <p:sldId xmlns:r="http://schemas.openxmlformats.org/officeDocument/2006/relationships" id="258" r:id="Rd8039cbfd63e44ad"/>
+    <p:sldId xmlns:r="http://schemas.openxmlformats.org/officeDocument/2006/relationships" id="259" r:id="R8ce307e59ff74c33"/>
+    <p:sldId xmlns:r="http://schemas.openxmlformats.org/officeDocument/2006/relationships" id="260" r:id="Re392dffe75f44b27"/>
+    <p:sldId xmlns:r="http://schemas.openxmlformats.org/officeDocument/2006/relationships" id="261" r:id="R5edbd9311f1a4683"/>
+    <p:sldId xmlns:r="http://schemas.openxmlformats.org/officeDocument/2006/relationships" id="262" r:id="Rdaa6d6aa115b46b0"/>
+    <p:sldId xmlns:r="http://schemas.openxmlformats.org/officeDocument/2006/relationships" id="263" r:id="Rcf3c0b79a2c741f1"/>
+    <p:sldId xmlns:r="http://schemas.openxmlformats.org/officeDocument/2006/relationships" id="264" r:id="R3640bab0a0084944"/>
+    <p:sldId xmlns:r="http://schemas.openxmlformats.org/officeDocument/2006/relationships" id="265" r:id="R6d7e5a7468b448b3"/>
+    <p:sldId xmlns:r="http://schemas.openxmlformats.org/officeDocument/2006/relationships" id="266" r:id="R022d82d5528b48b9"/>
+    <p:sldId xmlns:r="http://schemas.openxmlformats.org/officeDocument/2006/relationships" id="267" r:id="R90d49511bbf14774"/>
+    <p:sldId xmlns:r="http://schemas.openxmlformats.org/officeDocument/2006/relationships" id="268" r:id="R633100f1055749f2"/>
+    <p:sldId xmlns:r="http://schemas.openxmlformats.org/officeDocument/2006/relationships" id="269" r:id="R2dbaaf8d86574dac"/>
+    <p:sldId xmlns:r="http://schemas.openxmlformats.org/officeDocument/2006/relationships" id="270" r:id="R425f432cb04549f6"/>
+    <p:sldId xmlns:r="http://schemas.openxmlformats.org/officeDocument/2006/relationships" id="271" r:id="R01a3c36d308f4f0c"/>
   </p:sldIdLst>
   <p:sldSz cx="12192000" cy="6858000"/>
   <p:notesSz cx="6858000" cy="9144000"/>
@@ -457,7 +457,12 @@
           <a:lstStyle xmlns:a="http://schemas.openxmlformats.org/drawingml/2006/main"/>
           <a:p xmlns:a="http://schemas.openxmlformats.org/drawingml/2006/main">
             <a:r>
-              <a:t>Представиться. Система оценивает полноту исследования по введённым сведениям. Не прогнозирует цену. Материалы защиты подготовлены; проведение подтверждает студент после выступления.</a:t>
+              <a:t>Представиться: Кораблев Максим Игоревич, Б-ИС 24/23 Р. Версия материалов — 14 октября 2026 года. Система исследует полноту введённых сведений. Текущий план студента — недели 4–9; полный проект содержит дополнительные модули. Проведение защиты и оценка подтверждаются преподавателем отдельно.</a:t>
+            </a:r>
+          </a:p>
+          <a:p xmlns:a="http://schemas.openxmlformats.org/drawingml/2006/main">
+            <a:r>
+              <a:t>Источник: исходный код текущего проекта; docs/WEEKS_04_09.md; https://github.com/OverlordCrowley/SII. Локальная версия может быть новее опубликованной.</a:t>
             </a:r>
           </a:p>
         </p:txBody>
@@ -827,7 +832,7 @@
           <a:lstStyle xmlns:a="http://schemas.openxmlformats.org/drawingml/2006/main"/>
           <a:p xmlns:a="http://schemas.openxmlformats.org/drawingml/2006/main">
             <a:r>
-              <a:t>Показать вкладку «Локальная ИИ» и команду local-ai check. Qwen получает краткий экспертный разбор по явному запросу. Подключение необязательно, классическая система работает без него. Ручная проверка: docs/LOCAL_AI_QA_2026_10_07.md. Это отдельная готовая языковая модель, не нейросеть MLP, которую студент обучил на синтетическом датасете. Источники модели: https://huggingface.co/Qwen/Qwen3.5-2B и https://huggingface.co/unsloth/Qwen3.5-2B-GGUF. API: https://github.com/ggml-org/llama.cpp/blob/master/tools/server/README.md.</a:t>
+              <a:t>Версия 14 октября 2026 года. local_ai_runtime.py автоматически запускает Qwen на 8081 и дожидается готовности до интерфейса 8765. Нужны llama-server и .build/local-ai/Qwen3.5-2B-Q4_K_M.gguf. Внешний готовый сервер используется повторно; собственный останавливается при Ctrl+C. local_ai.py запрашивает JSON-выбор пунктов; explanations.py проверяет тему, восстанавливает пропущенные пункты и составляет пояснение по экспертным фактам. Показать вопрос «Как рассчитаны 20% ближайшей разблокировки?»: 2000000 / 10000000 × 100% = 20%. Можно спросить о несработавшем R13 на полном профиле. Неизвестная тема вызывает уточнение. Qwen готовая модель, собственные Bayes/MLP обучаются отдельно. Источники: project_assistant/local_ai_runtime.py, local_ai.py, explanations.py; docs/LOCAL_AI.md, VALIDATION.md.</a:t>
             </a:r>
           </a:p>
         </p:txBody>
@@ -897,7 +902,7 @@
           <a:lstStyle xmlns:a="http://schemas.openxmlformats.org/drawingml/2006/main"/>
           <a:p xmlns:a="http://schemas.openxmlformats.org/drawingml/2006/main">
             <a:r>
-              <a:t>57 тестов фактически прошли. Ручной тест с Qwen3.5-2B и llama-server b11461: соединение, ошибочные настройки, вопросы, отмена, смена проекта и экспорт. Desktop 1280 px, mobile 390 px, восемь тем. CI настроен для Python 3.10/3.12/3.14; удалённый запуск после публикации ещё не подтверждён. Источники: docs/LOCAL_AI_QA_2026_10_07.md, tests/, .github/workflows/tests.yml.</a:t>
+              <a:t>14 октября 2026 года повторно прошли 84 теста Python и 14 тестов интерфейса. Команды: python3 -m unittest discover -s tests -v; node --test tests/frontend.test.cjs. week415 проверяет вывод, временные фреймы/сеть, сохранение, интеграцию и метрики. Проверки настоящей Qwen: 26 сценариев подбора (21 генерация, 5 маршрутов без генерации) и 3 генерации на числовых границах. Автозапуск на 8081, освобождение портов и повторный запуск проверены на реальном процессе. Удалённый CI и проведение защиты не подтверждаются локальными тестами. Источник: docs/VALIDATION.md, tests/, .github/workflows/tests.yml.</a:t>
             </a:r>
           </a:p>
         </p:txBody>
@@ -967,12 +972,7 @@
           <a:lstStyle xmlns:a="http://schemas.openxmlformats.org/drawingml/2006/main"/>
           <a:p xmlns:a="http://schemas.openxmlformats.org/drawingml/2006/main">
             <a:r>
-              <a:t>docs/DEFENSE.md содержит сценарий на7–10мин и ответы. Факт проведения защиты и оценку подтверждает студент после выступления.</a:t>
-            </a:r>
-          </a:p>
-          <a:p xmlns:a="http://schemas.openxmlformats.org/drawingml/2006/main">
-            <a:r>
-              <a:t>Источник: код и данные проекта https://github.com/OverlordCrowley/SII.</a:t>
+              <a:t>Текущий учебный этап: docs/WEEKS_04_09.md и отдельная презентация 4–9. Материалы обновлены локально; коммит и публикация на GitHub выполняются отдельно. Наличие кода и слайдов не подтверждает выступление или оценку. Основной показ: week48 и команды frame; для полного семестра week415. Данные синтетические, внешние источники не проверяются автоматически, веса и пороги учебные. Источник: docs/DEFENSE.md, WEEKS_04_09.md, VALIDATION.md.</a:t>
             </a:r>
           </a:p>
         </p:txBody>
@@ -1042,12 +1042,12 @@
           <a:lstStyle xmlns:a="http://schemas.openxmlformats.org/drawingml/2006/main"/>
           <a:p xmlns:a="http://schemas.openxmlformats.org/drawingml/2006/main">
             <a:r>
-              <a:t>Показать data/knowledge.json и GitHub. 26 критериев, 28 правил, 6 фреймов, сеть 22/21.</a:t>
-            </a:r>
-          </a:p>
-          <a:p xmlns:a="http://schemas.openxmlformats.org/drawingml/2006/main">
-            <a:r>
-              <a:t>Источник: код и данные проекта https://github.com/OverlordCrowley/SII.</a:t>
+              <a:t>Неделя 4. Показать data/knowledge.json: criteria — определения вопросов, rules — условия и заключения, frames — типы объектов, network — карта понятий. Конкретные ответы true/false/null находятся в профиле пользователя, а не в определениях критериев. В базе 26 критериев, 28 правил, 6 типов фреймов, 22 узла и 21 связь. Команда: python3 -m project_assistant network path project unlocks. Ожидается путь project → token → supply → vesting → unlocks из четырёх связей. Ребро о токене описывает предметную область и не утверждает его наличие у каждого проекта. Публикацию последних локальных изменений на GitHub проверять отдельно.</a:t>
+            </a:r>
+          </a:p>
+          <a:p xmlns:a="http://schemas.openxmlformats.org/drawingml/2006/main">
+            <a:r>
+              <a:t>Источник: исходный код текущего проекта; docs/WEEKS_04_09.md; https://github.com/OverlordCrowley/SII. Локальная версия может быть новее опубликованной.</a:t>
             </a:r>
           </a:p>
         </p:txBody>
@@ -1117,12 +1117,12 @@
           <a:lstStyle xmlns:a="http://schemas.openxmlformats.org/drawingml/2006/main"/>
           <a:p xmlns:a="http://schemas.openxmlformats.org/drawingml/2006/main">
             <a:r>
-              <a:t>logic.py: обратный вывод начинает с цели. Раскрыть дерево R16.</a:t>
-            </a:r>
-          </a:p>
-          <a:p xmlns:a="http://schemas.openxmlformats.org/drawingml/2006/main">
-            <a:r>
-              <a:t>Источник: код и данные проекта https://github.com/OverlordCrowley/SII.</a:t>
+              <a:t>Неделя 5. logic.py: LogicalEngine.query() и explain(). Обратный вывод начинает с цели security_gap и ищет правило, способное её доказать. R16 требует двух явных отрицательных фактов audit_available=false и admin_controls_known=false. NOT false истинно; обе посылки AND подтверждены. Если факты не заданы, цель не доказана. Команда python3 -m project_assistant week48 показывает эту проверку. Фраза: я записал факты и правила и реализовал проверку цели по их посылкам.</a:t>
+            </a:r>
+          </a:p>
+          <a:p xmlns:a="http://schemas.openxmlformats.org/drawingml/2006/main">
+            <a:r>
+              <a:t>Источник: исходный код текущего проекта; docs/WEEKS_04_09.md; https://github.com/OverlordCrowley/SII. Локальная версия может быть новее опубликованной.</a:t>
             </a:r>
           </a:p>
         </p:txBody>
@@ -1192,12 +1192,12 @@
           <a:lstStyle xmlns:a="http://schemas.openxmlformats.org/drawingml/2006/main"/>
           <a:p xmlns:a="http://schemas.openxmlformats.org/drawingml/2006/main">
             <a:r>
-              <a:t>Парсер без eval. Приоритет NOT, AND, OR. Неизвестность не считается отрицанием. Команда week56.</a:t>
-            </a:r>
-          </a:p>
-          <a:p xmlns:a="http://schemas.openxmlformats.org/drawingml/2006/main">
-            <a:r>
-              <a:t>Источник: код и данные проекта https://github.com/OverlordCrowley/SII.</a:t>
+              <a:t>Неделя 6. logic.py: parse(), evaluate_node(), truth_table(), support_atoms(); assistant.py: proof_lines(). Приоритет NOT, затем AND, затем OR; скобки меняют порядок. Факты имеют состояния Да, Нет и Неизвестно; профильный null исключается из рабочей памяти и даёт неизвестность. NOT unknown остаётся unknown. false AND unknown=false; true OR unknown=true. R13: has_token AND (NOT vesting_disclosed OR NOT unlock_schedule_known). При токене и явном vesting=false достаточна одна ветвь OR. Объяснение показывает правило и достаточные посылки. Команда python3 -m project_assistant week56. NOT допускается только над исходными фактами.</a:t>
+            </a:r>
+          </a:p>
+          <a:p xmlns:a="http://schemas.openxmlformats.org/drawingml/2006/main">
+            <a:r>
+              <a:t>Источник: исходный код текущего проекта; docs/WEEKS_04_09.md; https://github.com/OverlordCrowley/SII. Локальная версия может быть новее опубликованной.</a:t>
             </a:r>
           </a:p>
         </p:txBody>
@@ -1267,12 +1267,12 @@
           <a:lstStyle xmlns:a="http://schemas.openxmlformats.org/drawingml/2006/main"/>
           <a:p xmlns:a="http://schemas.openxmlformats.org/drawingml/2006/main">
             <a:r>
-              <a:t>production.py: приоритеты, рабочая память, неподвижная точка. Показать цепочку R01–R06 полного профиля.</a:t>
-            </a:r>
-          </a:p>
-          <a:p xmlns:a="http://schemas.openxmlformats.org/drawingml/2006/main">
-            <a:r>
-              <a:t>Источник: код и данные проекта https://github.com/OverlordCrowley/SII.</a:t>
+              <a:t>Неделя 7. production.py: ProductionEngine.run(). Рабочая память начинается с исходных фактов. Правила упорядочены по приоритету и ID, истинные заключения добавляются в память. Цикл продолжается до отсутствия новых фактов. trace хранит шаг, условие, посылки и заключение. На ready.json срабатывают R01–R05 и затем R06; последний выводит research_ready. expert.py сверяет каждое заключение обратным выводом. Фраза: прямой вывод идёт от фактов к доступным заключениям; обратный — от выбранной цели к посылкам.</a:t>
+            </a:r>
+          </a:p>
+          <a:p xmlns:a="http://schemas.openxmlformats.org/drawingml/2006/main">
+            <a:r>
+              <a:t>Источник: исходный код текущего проекта; docs/WEEKS_04_09.md; https://github.com/OverlordCrowley/SII. Локальная версия может быть новее опубликованной.</a:t>
             </a:r>
           </a:p>
         </p:txBody>
@@ -1342,12 +1342,12 @@
           <a:lstStyle xmlns:a="http://schemas.openxmlformats.org/drawingml/2006/main"/>
           <a:p xmlns:a="http://schemas.openxmlformats.org/drawingml/2006/main">
             <a:r>
-              <a:t>FrameStore.describe показывает origins. Изменение focus у экземпляра не изменяет defi.</a:t>
-            </a:r>
-          </a:p>
-          <a:p xmlns:a="http://schemas.openxmlformats.org/drawingml/2006/main">
-            <a:r>
-              <a:t>Источник: код и данные проекта https://github.com/OverlordCrowley/SII.</a:t>
+              <a:t>Неделя 8. frames.py: FrameStore.describe(), create(), get(), set(). Фрейм содержит parent и slots. crypto_project задаёт quote_currency=USD, метод и требования к источникам. defi добавляет focus и security_focus; конкретный demo_protocol наследует значения по цепочке. origins показывает родителя каждого слота. Локальное переопределение focus не изменяет родителя. Циклы и отсутствующие родители отклоняются. week48 выполняет пример без сохранения в пользовательское состояние. Изменение фрейма меняет описание объекта, а не продукционные правила и веса балла.</a:t>
+            </a:r>
+          </a:p>
+          <a:p xmlns:a="http://schemas.openxmlformats.org/drawingml/2006/main">
+            <a:r>
+              <a:t>Источник: исходный код текущего проекта; docs/WEEKS_04_09.md; https://github.com/OverlordCrowley/SII. Локальная версия может быть новее опубликованной.</a:t>
             </a:r>
           </a:p>
         </p:txBody>
@@ -1417,12 +1417,37 @@
           <a:lstStyle xmlns:a="http://schemas.openxmlformats.org/drawingml/2006/main"/>
           <a:p xmlns:a="http://schemas.openxmlformats.org/drawingml/2006/main">
             <a:r>
-              <a:t>workbench.py, frame create/set/find/show. JSON-значения; .state/frames.json; после перезапуска новые типы доступны в форме.</a:t>
-            </a:r>
-          </a:p>
-          <a:p xmlns:a="http://schemas.openxmlformats.org/drawingml/2006/main">
-            <a:r>
-              <a:t>Источник: код и данные проекта https://github.com/OverlordCrowley/SII.</a:t>
+              <a:t>Неделя 9. Выполнять из crypto-project-assistant. Сначала создать новый учебный файл demo-frames.json; create для одного имени выполнить один раз. Полные команды:</a:t>
+            </a:r>
+          </a:p>
+          <a:p xmlns:a="http://schemas.openxmlformats.org/drawingml/2006/main">
+            <a:r>
+              <a:t>python3 -m project_assistant frame --state demo-frames.json create my_protocol defi</a:t>
+            </a:r>
+          </a:p>
+          <a:p xmlns:a="http://schemas.openxmlformats.org/drawingml/2006/main">
+            <a:r>
+              <a:t>python3 -m project_assistant frame --state demo-frames.json set my_protocol reviewed true</a:t>
+            </a:r>
+          </a:p>
+          <a:p xmlns:a="http://schemas.openxmlformats.org/drawingml/2006/main">
+            <a:r>
+              <a:t>python3 -m project_assistant frame --state demo-frames.json find reviewed true</a:t>
+            </a:r>
+          </a:p>
+          <a:p xmlns:a="http://schemas.openxmlformats.org/drawingml/2006/main">
+            <a:r>
+              <a:t>python3 -m project_assistant frame --state demo-frames.json show my_protocol</a:t>
+            </a:r>
+          </a:p>
+          <a:p xmlns:a="http://schemas.openxmlformats.org/drawingml/2006/main">
+            <a:r>
+              <a:t>Ожидается my_protocol в результате find, reviewed=true и унаследованный quote_currency=USD в show. workbench.py вызывает FrameStore; файл заново загружается каждой командой. Поиск учитывает наследование и тип JSON-значения. Без --state изменения находятся в .state/frames.json; браузерный сервер перезапустить после редактирования. Веб-редактора фреймов нет. reviewed — учебное свойство, а не критерий анкеты. Подробности: docs/WEEKS_04_09.md.</a:t>
+            </a:r>
+          </a:p>
+          <a:p xmlns:a="http://schemas.openxmlformats.org/drawingml/2006/main">
+            <a:r>
+              <a:t>Источник: исходный код текущего проекта; docs/WEEKS_04_09.md; https://github.com/OverlordCrowley/SII. Локальная версия может быть новее опубликованной.</a:t>
             </a:r>
           </a:p>
         </p:txBody>
@@ -1640,7 +1665,7 @@
   </p:cSld>
   <p:clrMap bg1="lt1" tx1="dk1" bg2="lt2" tx2="dk2" accent1="accent1" accent2="accent2" accent3="accent3" accent4="accent4" accent5="accent5" accent6="accent6" hlink="hlink" folHlink="folHlink"/>
   <p:sldLayoutIdLst>
-    <p:sldLayoutId xmlns:r="http://schemas.openxmlformats.org/officeDocument/2006/relationships" id="2147483649" r:id="R30fbe7ad57ef439a"/>
+    <p:sldLayoutId xmlns:r="http://schemas.openxmlformats.org/officeDocument/2006/relationships" id="2147483649" r:id="Rd3000e650c7645b0"/>
   </p:sldLayoutIdLst>
   <p:txStyles>
     <p:titleStyle>
@@ -2168,7 +2193,7 @@
 </file>
 
 <file path=ppt/slides/charts/chart1.xml><?xml version="1.0" encoding="utf-8"?>
-<c:chartSpace xmlns:c="http://schemas.openxmlformats.org/drawingml/2006/chart" xmlns:r="http://schemas.openxmlformats.org/officeDocument/2006/relationships">
+<c:chartSpace xmlns:c="http://schemas.openxmlformats.org/drawingml/2006/chart" xmlns:ns1="http://schemas.openxmlformats.org/drawingml/2006/main" xmlns:r="http://schemas.openxmlformats.org/officeDocument/2006/relationships">
   <c:lang val="en-US"/>
   <c:chart>
     <c:plotArea>
@@ -2183,9 +2208,9 @@
             <c:v>Test accuracy</c:v>
           </c:tx>
           <c:spPr>
-            <a:solidFill xmlns:a="http://schemas.openxmlformats.org/drawingml/2006/main">
-              <a:srgbClr val="5947B8"/>
-            </a:solidFill>
+            <ns1:solidFill>
+              <ns1:srgbClr val="5947B8"/>
+            </ns1:solidFill>
           </c:spPr>
           <c:cat>
             <c:strRef>
@@ -2225,20 +2250,20 @@
         </c:ser>
         <c:dLbls>
           <c:txPr>
-            <a:bodyPr xmlns:a="http://schemas.openxmlformats.org/drawingml/2006/main" anchorCtr="1"/>
-            <a:lstStyle xmlns:a="http://schemas.openxmlformats.org/drawingml/2006/main"/>
-            <a:p xmlns:a="http://schemas.openxmlformats.org/drawingml/2006/main">
-              <a:pPr>
-                <a:defRPr sz="2025" b="1">
-                  <a:solidFill>
-                    <a:srgbClr val="202739"/>
-                  </a:solidFill>
-                  <a:latin typeface="Helvetica Neue"/>
-                  <a:ea typeface="Helvetica Neue"/>
-                  <a:cs typeface="Helvetica Neue"/>
-                </a:defRPr>
-              </a:pPr>
-            </a:p>
+            <ns1:bodyPr anchorCtr="1"/>
+            <ns1:lstStyle/>
+            <ns1:p>
+              <ns1:pPr>
+                <ns1:defRPr sz="2025" b="1">
+                  <ns1:solidFill>
+                    <ns1:srgbClr val="202739"/>
+                  </ns1:solidFill>
+                  <ns1:latin typeface="Helvetica Neue"/>
+                  <ns1:ea typeface="Helvetica Neue"/>
+                  <ns1:cs typeface="Helvetica Neue"/>
+                </ns1:defRPr>
+              </ns1:pPr>
+            </ns1:p>
           </c:txPr>
           <c:dLblPos val="outEnd"/>
           <c:showLegendKey val="0"/>
@@ -2264,28 +2289,28 @@
         <c:majorTickMark val="none"/>
         <c:minorTickMark val="none"/>
         <c:spPr>
-          <a:ln xmlns:a="http://schemas.openxmlformats.org/drawingml/2006/main" w="9525">
-            <a:solidFill>
-              <a:srgbClr val="D4D4D4"/>
-            </a:solidFill>
-            <a:prstDash val="solid"/>
-          </a:ln>
+          <ns1:ln w="9525">
+            <ns1:solidFill>
+              <ns1:srgbClr val="D4D4D4"/>
+            </ns1:solidFill>
+            <ns1:prstDash val="solid"/>
+          </ns1:ln>
         </c:spPr>
         <c:txPr>
-          <a:bodyPr xmlns:a="http://schemas.openxmlformats.org/drawingml/2006/main" anchorCtr="1"/>
-          <a:lstStyle xmlns:a="http://schemas.openxmlformats.org/drawingml/2006/main"/>
-          <a:p xmlns:a="http://schemas.openxmlformats.org/drawingml/2006/main">
-            <a:pPr>
-              <a:defRPr sz="1950">
-                <a:solidFill>
-                  <a:srgbClr val="202739"/>
-                </a:solidFill>
-                <a:latin typeface="Helvetica Neue"/>
-                <a:ea typeface="Helvetica Neue"/>
-                <a:cs typeface="Helvetica Neue"/>
-              </a:defRPr>
-            </a:pPr>
-          </a:p>
+          <ns1:bodyPr anchorCtr="1"/>
+          <ns1:lstStyle/>
+          <ns1:p>
+            <ns1:pPr>
+              <ns1:defRPr sz="1950">
+                <ns1:solidFill>
+                  <ns1:srgbClr val="202739"/>
+                </ns1:solidFill>
+                <ns1:latin typeface="Helvetica Neue"/>
+                <ns1:ea typeface="Helvetica Neue"/>
+                <ns1:cs typeface="Helvetica Neue"/>
+              </ns1:defRPr>
+            </ns1:pPr>
+          </ns1:p>
         </c:txPr>
         <c:crossAx val="48672768"/>
       </c:catAx>
@@ -2300,39 +2325,39 @@
         <c:axPos val="l"/>
         <c:majorGridlines>
           <c:spPr>
-            <a:ln xmlns:a="http://schemas.openxmlformats.org/drawingml/2006/main" w="9525">
-              <a:solidFill>
-                <a:srgbClr val="E4E7ED"/>
-              </a:solidFill>
-            </a:ln>
+            <ns1:ln w="9525">
+              <ns1:solidFill>
+                <ns1:srgbClr val="E4E7ED"/>
+              </ns1:solidFill>
+            </ns1:ln>
           </c:spPr>
         </c:majorGridlines>
         <c:numFmt formatCode="0%"/>
         <c:majorTickMark val="none"/>
         <c:minorTickMark val="none"/>
         <c:spPr>
-          <a:ln xmlns:a="http://schemas.openxmlformats.org/drawingml/2006/main" w="9525">
-            <a:solidFill>
-              <a:srgbClr val="D4D4D4"/>
-            </a:solidFill>
-            <a:prstDash val="solid"/>
-          </a:ln>
+          <ns1:ln w="9525">
+            <ns1:solidFill>
+              <ns1:srgbClr val="D4D4D4"/>
+            </ns1:solidFill>
+            <ns1:prstDash val="solid"/>
+          </ns1:ln>
         </c:spPr>
         <c:txPr>
-          <a:bodyPr xmlns:a="http://schemas.openxmlformats.org/drawingml/2006/main" anchorCtr="1"/>
-          <a:lstStyle xmlns:a="http://schemas.openxmlformats.org/drawingml/2006/main"/>
-          <a:p xmlns:a="http://schemas.openxmlformats.org/drawingml/2006/main">
-            <a:pPr>
-              <a:defRPr sz="1875">
-                <a:solidFill>
-                  <a:srgbClr val="586273"/>
-                </a:solidFill>
-                <a:latin typeface="Helvetica Neue"/>
-                <a:ea typeface="Helvetica Neue"/>
-                <a:cs typeface="Helvetica Neue"/>
-              </a:defRPr>
-            </a:pPr>
-          </a:p>
+          <ns1:bodyPr anchorCtr="1"/>
+          <ns1:lstStyle/>
+          <ns1:p>
+            <ns1:pPr>
+              <ns1:defRPr sz="1875">
+                <ns1:solidFill>
+                  <ns1:srgbClr val="586273"/>
+                </ns1:solidFill>
+                <ns1:latin typeface="Helvetica Neue"/>
+                <ns1:ea typeface="Helvetica Neue"/>
+                <ns1:cs typeface="Helvetica Neue"/>
+              </ns1:defRPr>
+            </ns1:pPr>
+          </ns1:p>
         </c:txPr>
         <c:crossAx val="48650112"/>
         <c:crossBetween val="between"/>
@@ -2793,7 +2818,13 @@
       </p:sp>
       <p:graphicFrame>
         <p:nvGraphicFramePr>
-          <p:cNvPr id="11" name="Chart"/>
+          <p:cNvPr id="11" name="Chart">
+            <a:extLst xmlns:a="http://schemas.openxmlformats.org/drawingml/2006/main">
+              <a:ext uri="{FF2B5EF4-FFF2-40B4-BE49-F238E27FC236}">
+                <a16:creationId xmlns:a16="http://schemas.microsoft.com/office/drawing/2014/main" id="{4D6B0F8D-E13B-4AB7-A032-757FCF8D68AA}"/>
+              </a:ext>
+            </a:extLst>
+          </p:cNvPr>
           <p:cNvGraphicFramePr/>
           <p:nvPr/>
         </p:nvGraphicFramePr>
@@ -2803,7 +2834,7 @@
         </p:xfrm>
         <a:graphic xmlns:a="http://schemas.openxmlformats.org/drawingml/2006/main">
           <a:graphicData uri="http://schemas.openxmlformats.org/drawingml/2006/chart">
-            <c:chart xmlns:r="http://schemas.openxmlformats.org/officeDocument/2006/relationships" xmlns:c="http://schemas.openxmlformats.org/drawingml/2006/chart" r:id="R9d5f00b393fd4791"/>
+            <c:chart xmlns:r="http://schemas.openxmlformats.org/officeDocument/2006/relationships" xmlns:c="http://schemas.openxmlformats.org/drawingml/2006/chart" r:id="R9062b48ae5004d36"/>
           </a:graphicData>
         </a:graphic>
       </p:graphicFrame>
@@ -4196,14 +4227,20 @@
       </p:sp>
       <p:pic>
         <p:nvPicPr>
-          <p:cNvPr id="12" name=""/>
+          <p:cNvPr id="12" name="">
+            <a:extLst xmlns:a="http://schemas.openxmlformats.org/drawingml/2006/main">
+              <a:ext uri="{FF2B5EF4-FFF2-40B4-BE49-F238E27FC236}">
+                <a16:creationId xmlns:a16="http://schemas.microsoft.com/office/drawing/2014/main" id="{3B59437B-ED6C-4D70-9D97-D4B7E6F47DD6}"/>
+              </a:ext>
+            </a:extLst>
+          </p:cNvPr>
           <p:cNvPicPr>
             <a:picLocks xmlns:a="http://schemas.openxmlformats.org/drawingml/2006/main" noChangeAspect="1"/>
           </p:cNvPicPr>
           <p:nvPr/>
         </p:nvPicPr>
         <p:blipFill>
-          <a:blip xmlns:r="http://schemas.openxmlformats.org/officeDocument/2006/relationships" xmlns:a="http://schemas.openxmlformats.org/drawingml/2006/main" r:embed="R089287112e8f48ad"/>
+          <a:blip xmlns:r="http://schemas.openxmlformats.org/officeDocument/2006/relationships" xmlns:a="http://schemas.openxmlformats.org/drawingml/2006/main" r:embed="R36147e83af5e472e"/>
           <a:stretch xmlns:a="http://schemas.openxmlformats.org/drawingml/2006/main"/>
         </p:blipFill>
         <p:spPr>
@@ -4279,6 +4316,7 @@
           <a:lstStyle xmlns:a="http://schemas.openxmlformats.org/drawingml/2006/main"/>
           <a:p xmlns:a="http://schemas.openxmlformats.org/drawingml/2006/main">
             <a:pPr>
+              <a:buNone/>
               <a:defRPr sz="3450" b="1">
                 <a:solidFill>
                   <a:srgbClr val="202739"/>
@@ -4336,6 +4374,7 @@
           <a:lstStyle xmlns:a="http://schemas.openxmlformats.org/drawingml/2006/main"/>
           <a:p xmlns:a="http://schemas.openxmlformats.org/drawingml/2006/main">
             <a:pPr>
+              <a:buNone/>
               <a:defRPr sz="2400" b="1">
                 <a:solidFill>
                   <a:srgbClr val="5947B8"/>
@@ -4354,7 +4393,7 @@
                 <a:ea typeface="Helvetica Neue"/>
                 <a:cs typeface="Helvetica Neue"/>
               </a:rPr>
-              <a:t>Модель на этом компьютере</a:t>
+              <a:t>Автозапуск при старте проекта</a:t>
             </a:r>
           </a:p>
         </p:txBody>
@@ -4393,6 +4432,7 @@
           <a:lstStyle xmlns:a="http://schemas.openxmlformats.org/drawingml/2006/main"/>
           <a:p xmlns:a="http://schemas.openxmlformats.org/drawingml/2006/main">
             <a:pPr>
+              <a:buNone/>
               <a:defRPr sz="2175" b="0">
                 <a:solidFill>
                   <a:srgbClr val="202739"/>
@@ -4411,7 +4451,31 @@
                 <a:ea typeface="Helvetica Neue"/>
                 <a:cs typeface="Helvetica Neue"/>
               </a:rPr>
-              <a:t>Qwen3.5-2B, GGUF Q4_K_M. Файл весов 1,28 ГБ, контекст 8192.</a:t>
+              <a:t>Qwen3.5-2B на 8081; интерфейс на 8765 после готовности.</a:t>
+            </a:r>
+          </a:p>
+          <a:p xmlns:a="http://schemas.openxmlformats.org/drawingml/2006/main">
+            <a:pPr>
+              <a:buNone/>
+              <a:defRPr sz="2175" b="0">
+                <a:solidFill>
+                  <a:srgbClr val="202739"/>
+                </a:solidFill>
+                <a:latin typeface="Helvetica Neue"/>
+                <a:ea typeface="Helvetica Neue"/>
+                <a:cs typeface="Helvetica Neue"/>
+              </a:defRPr>
+            </a:pPr>
+            <a:r>
+              <a:rPr sz="2175" b="0">
+                <a:solidFill>
+                  <a:srgbClr val="202739"/>
+                </a:solidFill>
+                <a:latin typeface="Helvetica Neue"/>
+                <a:ea typeface="Helvetica Neue"/>
+                <a:cs typeface="Helvetica Neue"/>
+              </a:rPr>
+              <a:t>GGUF Q4_K_M, 1,28 ГБ; контекст 8192.</a:t>
             </a:r>
           </a:p>
         </p:txBody>
@@ -4450,6 +4514,7 @@
           <a:lstStyle xmlns:a="http://schemas.openxmlformats.org/drawingml/2006/main"/>
           <a:p xmlns:a="http://schemas.openxmlformats.org/drawingml/2006/main">
             <a:pPr>
+              <a:buNone/>
               <a:defRPr sz="2400" b="1">
                 <a:solidFill>
                   <a:srgbClr val="5947B8"/>
@@ -4468,7 +4533,7 @@
                 <a:ea typeface="Helvetica Neue"/>
                 <a:cs typeface="Helvetica Neue"/>
               </a:rPr>
-              <a:t>Пояснение текущего разбора</a:t>
+              <a:t>Ответ по заданному вопросу</a:t>
             </a:r>
           </a:p>
         </p:txBody>
@@ -4507,6 +4572,7 @@
           <a:lstStyle xmlns:a="http://schemas.openxmlformats.org/drawingml/2006/main"/>
           <a:p xmlns:a="http://schemas.openxmlformats.org/drawingml/2006/main">
             <a:pPr>
+              <a:buNone/>
               <a:defRPr sz="2175" b="0">
                 <a:solidFill>
                   <a:srgbClr val="202739"/>
@@ -4525,7 +4591,31 @@
                 <a:ea typeface="Helvetica Neue"/>
                 <a:cs typeface="Helvetica Neue"/>
               </a:rPr>
-              <a:t>Вкладка «Локальная ИИ»: адрес, проверка сервера, вопрос и экспорт ответа.</a:t>
+              <a:t>Qwen выбирает идентификаторы. Сервер проверяет темы</a:t>
+            </a:r>
+          </a:p>
+          <a:p xmlns:a="http://schemas.openxmlformats.org/drawingml/2006/main">
+            <a:pPr>
+              <a:buNone/>
+              <a:defRPr sz="2175" b="0">
+                <a:solidFill>
+                  <a:srgbClr val="202739"/>
+                </a:solidFill>
+                <a:latin typeface="Helvetica Neue"/>
+                <a:ea typeface="Helvetica Neue"/>
+                <a:cs typeface="Helvetica Neue"/>
+              </a:defRPr>
+            </a:pPr>
+            <a:r>
+              <a:rPr sz="2175" b="0">
+                <a:solidFill>
+                  <a:srgbClr val="202739"/>
+                </a:solidFill>
+                <a:latin typeface="Helvetica Neue"/>
+                <a:ea typeface="Helvetica Neue"/>
+                <a:cs typeface="Helvetica Neue"/>
+              </a:rPr>
+              <a:t>и формирует пояснение из экспертного разбора.</a:t>
             </a:r>
           </a:p>
         </p:txBody>
@@ -4564,6 +4654,7 @@
           <a:lstStyle xmlns:a="http://schemas.openxmlformats.org/drawingml/2006/main"/>
           <a:p xmlns:a="http://schemas.openxmlformats.org/drawingml/2006/main">
             <a:pPr>
+              <a:buNone/>
               <a:defRPr sz="2400" b="1">
                 <a:solidFill>
                   <a:srgbClr val="5947B8"/>
@@ -4582,7 +4673,7 @@
                 <a:ea typeface="Helvetica Neue"/>
                 <a:cs typeface="Helvetica Neue"/>
               </a:rPr>
-              <a:t>Экспертный вывод сохраняется</a:t>
+              <a:t>Факты, балл и статус сохраняются</a:t>
             </a:r>
           </a:p>
         </p:txBody>
@@ -4621,6 +4712,7 @@
           <a:lstStyle xmlns:a="http://schemas.openxmlformats.org/drawingml/2006/main"/>
           <a:p xmlns:a="http://schemas.openxmlformats.org/drawingml/2006/main">
             <a:pPr>
+              <a:buNone/>
               <a:defRPr sz="2175" b="0">
                 <a:solidFill>
                   <a:srgbClr val="202739"/>
@@ -4639,7 +4731,31 @@
                 <a:ea typeface="Helvetica Neue"/>
                 <a:cs typeface="Helvetica Neue"/>
               </a:rPr>
-              <a:t>Правила определяют балл и статус. Ответ модели может содержать ошибки.</a:t>
+              <a:t>Показываются условия правил, формулы и пороги.</a:t>
+            </a:r>
+          </a:p>
+          <a:p xmlns:a="http://schemas.openxmlformats.org/drawingml/2006/main">
+            <a:pPr>
+              <a:buNone/>
+              <a:defRPr sz="2175" b="0">
+                <a:solidFill>
+                  <a:srgbClr val="202739"/>
+                </a:solidFill>
+                <a:latin typeface="Helvetica Neue"/>
+                <a:ea typeface="Helvetica Neue"/>
+                <a:cs typeface="Helvetica Neue"/>
+              </a:defRPr>
+            </a:pPr>
+            <a:r>
+              <a:rPr sz="2175" b="0">
+                <a:solidFill>
+                  <a:srgbClr val="202739"/>
+                </a:solidFill>
+                <a:latin typeface="Helvetica Neue"/>
+                <a:ea typeface="Helvetica Neue"/>
+                <a:cs typeface="Helvetica Neue"/>
+              </a:rPr>
+              <a:t>Нераспознанный вопрос требует уточнения.</a:t>
             </a:r>
           </a:p>
         </p:txBody>
@@ -4678,6 +4794,7 @@
           <a:lstStyle xmlns:a="http://schemas.openxmlformats.org/drawingml/2006/main"/>
           <a:p xmlns:a="http://schemas.openxmlformats.org/drawingml/2006/main">
             <a:pPr>
+              <a:buNone/>
               <a:defRPr sz="1725" b="0">
                 <a:solidFill>
                   <a:srgbClr val="586273"/>
@@ -4735,6 +4852,7 @@
           <a:lstStyle xmlns:a="http://schemas.openxmlformats.org/drawingml/2006/main"/>
           <a:p xmlns:a="http://schemas.openxmlformats.org/drawingml/2006/main">
             <a:pPr>
+              <a:buNone/>
               <a:defRPr sz="1725" b="0">
                 <a:solidFill>
                   <a:srgbClr val="586273"/>
@@ -5014,7 +5132,7 @@
                 <a:ea typeface="Helvetica Neue"/>
                 <a:cs typeface="Helvetica Neue"/>
               </a:rPr>
-              <a:t>57 автоматических тестов</a:t>
+              <a:t>84 теста Python и 14 тестов интерфейса</a:t>
             </a:r>
           </a:p>
         </p:txBody>
@@ -5072,7 +5190,31 @@
                 <a:ea typeface="Helvetica Neue"/>
                 <a:cs typeface="Helvetica Neue"/>
               </a:rPr>
-              <a:t>Логика, фреймы, сеть, модели, метрики, API, числа, алиасы и llama.cpp.</a:t>
+              <a:t>Вывод, фреймы, модели, API, подбор по вопросу,</a:t>
+            </a:r>
+          </a:p>
+          <a:p xmlns:a="http://schemas.openxmlformats.org/drawingml/2006/main">
+            <a:pPr>
+              <a:buNone/>
+              <a:defRPr sz="2175" b="0">
+                <a:solidFill>
+                  <a:srgbClr val="202739"/>
+                </a:solidFill>
+                <a:latin typeface="Helvetica Neue"/>
+                <a:ea typeface="Helvetica Neue"/>
+                <a:cs typeface="Helvetica Neue"/>
+              </a:defRPr>
+            </a:pPr>
+            <a:r>
+              <a:rPr sz="2175" b="0">
+                <a:solidFill>
+                  <a:srgbClr val="202739"/>
+                </a:solidFill>
+                <a:latin typeface="Helvetica Neue"/>
+                <a:ea typeface="Helvetica Neue"/>
+                <a:cs typeface="Helvetica Neue"/>
+              </a:rPr>
+              <a:t>числовые границы и автозапуск Qwen.</a:t>
             </a:r>
           </a:p>
         </p:txBody>
@@ -5130,7 +5272,7 @@
                 <a:ea typeface="Helvetica Neue"/>
                 <a:cs typeface="Helvetica Neue"/>
               </a:rPr>
-              <a:t>Ручная проверка интерфейса</a:t>
+              <a:t>Проверка настоящей модели</a:t>
             </a:r>
           </a:p>
         </p:txBody>
@@ -5188,7 +5330,31 @@
                 <a:ea typeface="Helvetica Neue"/>
                 <a:cs typeface="Helvetica Neue"/>
               </a:rPr>
-              <a:t>Алиасы, экспорт, запросы Qwen, отмена и восемь тем на экране 390 px.</a:t>
+              <a:t>Ответ Qwen на 8081; остановка освобождает порты.</a:t>
+            </a:r>
+          </a:p>
+          <a:p xmlns:a="http://schemas.openxmlformats.org/drawingml/2006/main">
+            <a:pPr>
+              <a:buNone/>
+              <a:defRPr sz="2175" b="0">
+                <a:solidFill>
+                  <a:srgbClr val="202739"/>
+                </a:solidFill>
+                <a:latin typeface="Helvetica Neue"/>
+                <a:ea typeface="Helvetica Neue"/>
+                <a:cs typeface="Helvetica Neue"/>
+              </a:defRPr>
+            </a:pPr>
+            <a:r>
+              <a:rPr sz="2175" b="0">
+                <a:solidFill>
+                  <a:srgbClr val="202739"/>
+                </a:solidFill>
+                <a:latin typeface="Helvetica Neue"/>
+                <a:ea typeface="Helvetica Neue"/>
+                <a:cs typeface="Helvetica Neue"/>
+              </a:rPr>
+              <a:t>Повторный запуск автоматически восстанавливает модель.</a:t>
             </a:r>
           </a:p>
         </p:txBody>
@@ -5246,7 +5412,7 @@
                 <a:ea typeface="Helvetica Neue"/>
                 <a:cs typeface="Helvetica Neue"/>
               </a:rPr>
-              <a:t>Воспроизводимый запуск</a:t>
+              <a:t>Команды и материалы</a:t>
             </a:r>
           </a:p>
         </p:txBody>
@@ -5304,7 +5470,31 @@
                 <a:ea typeface="Helvetica Neue"/>
                 <a:cs typeface="Helvetica Neue"/>
               </a:rPr>
-              <a:t>Python 3.10+, demo, week415, unittest. Для Qwen нужен llama-server.</a:t>
+              <a:t>week48 + команды frame — недели 4–9; week415 — полный показ.</a:t>
+            </a:r>
+          </a:p>
+          <a:p xmlns:a="http://schemas.openxmlformats.org/drawingml/2006/main">
+            <a:pPr>
+              <a:buNone/>
+              <a:defRPr sz="2175" b="0">
+                <a:solidFill>
+                  <a:srgbClr val="202739"/>
+                </a:solidFill>
+                <a:latin typeface="Helvetica Neue"/>
+                <a:ea typeface="Helvetica Neue"/>
+                <a:cs typeface="Helvetica Neue"/>
+              </a:defRPr>
+            </a:pPr>
+            <a:r>
+              <a:rPr sz="2175" b="0">
+                <a:solidFill>
+                  <a:srgbClr val="202739"/>
+                </a:solidFill>
+                <a:latin typeface="Helvetica Neue"/>
+                <a:ea typeface="Helvetica Neue"/>
+                <a:cs typeface="Helvetica Neue"/>
+              </a:rPr>
+              <a:t>Подготовка материалов не подтверждает проведённую защиту.</a:t>
             </a:r>
           </a:p>
         </p:txBody>
@@ -5565,7 +5755,7 @@
                 <a:ea typeface="Helvetica Neue"/>
                 <a:cs typeface="Helvetica Neue"/>
               </a:rPr>
-              <a:t>Материалы</a:t>
+              <a:t>Учебный разбор недель 4–9</a:t>
             </a:r>
           </a:p>
         </p:txBody>
@@ -5623,7 +5813,31 @@
                 <a:ea typeface="Helvetica Neue"/>
                 <a:cs typeface="Helvetica Neue"/>
               </a:rPr>
-              <a:t>README, соответствие неделям, код, данные, веса и презентация.</a:t>
+              <a:t>Отдельные слайды, понятные команды и ожидаемые результаты.</a:t>
+            </a:r>
+          </a:p>
+          <a:p xmlns:a="http://schemas.openxmlformats.org/drawingml/2006/main">
+            <a:pPr>
+              <a:buNone/>
+              <a:defRPr sz="2175" b="0">
+                <a:solidFill>
+                  <a:srgbClr val="202739"/>
+                </a:solidFill>
+                <a:latin typeface="Helvetica Neue"/>
+                <a:ea typeface="Helvetica Neue"/>
+                <a:cs typeface="Helvetica Neue"/>
+              </a:defRPr>
+            </a:pPr>
+            <a:r>
+              <a:rPr sz="2175" b="0">
+                <a:solidFill>
+                  <a:srgbClr val="202739"/>
+                </a:solidFill>
+                <a:latin typeface="Helvetica Neue"/>
+                <a:ea typeface="Helvetica Neue"/>
+                <a:cs typeface="Helvetica Neue"/>
+              </a:rPr>
+              <a:t>README, код, данные и полная презентация 4–15.</a:t>
             </a:r>
           </a:p>
         </p:txBody>
@@ -5681,7 +5895,7 @@
                 <a:ea typeface="Helvetica Neue"/>
                 <a:cs typeface="Helvetica Neue"/>
               </a:rPr>
-              <a:t>Показ</a:t>
+              <a:t>Перед сдачей</a:t>
             </a:r>
           </a:p>
         </p:txBody>
@@ -5739,7 +5953,31 @@
                 <a:ea typeface="Helvetica Neue"/>
                 <a:cs typeface="Helvetica Neue"/>
               </a:rPr>
-              <a:t>week415 → браузер → объяснение правил → модели → экспорт отчёта.</a:t>
+              <a:t>Сверить публикацию текущей версии на GitHub.</a:t>
+            </a:r>
+          </a:p>
+          <a:p xmlns:a="http://schemas.openxmlformats.org/drawingml/2006/main">
+            <a:pPr>
+              <a:buNone/>
+              <a:defRPr sz="2175" b="0">
+                <a:solidFill>
+                  <a:srgbClr val="202739"/>
+                </a:solidFill>
+                <a:latin typeface="Helvetica Neue"/>
+                <a:ea typeface="Helvetica Neue"/>
+                <a:cs typeface="Helvetica Neue"/>
+              </a:defRPr>
+            </a:pPr>
+            <a:r>
+              <a:rPr sz="2175" b="0">
+                <a:solidFill>
+                  <a:srgbClr val="202739"/>
+                </a:solidFill>
+                <a:latin typeface="Helvetica Neue"/>
+                <a:ea typeface="Helvetica Neue"/>
+                <a:cs typeface="Helvetica Neue"/>
+              </a:rPr>
+              <a:t>Выполнить показ и ответить на вопросы преподавателя.</a:t>
             </a:r>
           </a:p>
         </p:txBody>
@@ -6174,7 +6412,7 @@
                 <a:ea typeface="Helvetica Neue"/>
                 <a:cs typeface="Helvetica Neue"/>
               </a:rPr>
-              <a:t>Выявить пробелы в исследовании продукта, токена и безопасности.</a:t>
+              <a:t>Исследовать полноту сведений о продукте, токене и безопасности.</a:t>
             </a:r>
           </a:p>
         </p:txBody>
@@ -7174,7 +7412,7 @@
                 <a:ea typeface="Helvetica Neue"/>
                 <a:cs typeface="Helvetica Neue"/>
               </a:rPr>
-              <a:t>AND требует всех посылок. Для OR достаточно подтверждённой ветви.</a:t>
+              <a:t>AND — все условия; OR — хотя бы одно условие.</a:t>
             </a:r>
           </a:p>
         </p:txBody>
@@ -7290,7 +7528,7 @@
                 <a:ea typeface="Helvetica Neue"/>
                 <a:cs typeface="Helvetica Neue"/>
               </a:rPr>
-              <a:t>NOT false = true. NOT unknown = unknown.</a:t>
+              <a:t>Нет данных ≠ «Нет». NOT unknown = unknown.</a:t>
             </a:r>
           </a:p>
         </p:txBody>
@@ -7348,7 +7586,7 @@
                 <a:ea typeface="Helvetica Neue"/>
                 <a:cs typeface="Helvetica Neue"/>
               </a:rPr>
-              <a:t>Доказательство результата</a:t>
+              <a:t>Почему сработало правило</a:t>
             </a:r>
           </a:p>
         </p:txBody>
@@ -7406,7 +7644,7 @@
                 <a:ea typeface="Helvetica Neue"/>
                 <a:cs typeface="Helvetica Neue"/>
               </a:rPr>
-              <a:t>Номер правила, условие и исходные факты с основаниями.</a:t>
+              <a:t>Дерево показывает правило и посылки. Для OR — достаточную ветвь.</a:t>
             </a:r>
           </a:p>
         </p:txBody>
@@ -8575,7 +8813,7 @@
                 <a:ea typeface="Helvetica Neue"/>
                 <a:cs typeface="Helvetica Neue"/>
               </a:rPr>
-              <a:t>frame create my_protocol defi</a:t>
+              <a:t>frame --state demo-frames.json create my_protocol defi</a:t>
             </a:r>
           </a:p>
           <a:p xmlns:a="http://schemas.openxmlformats.org/drawingml/2006/main">
@@ -8599,7 +8837,7 @@
                 <a:ea typeface="Helvetica Neue"/>
                 <a:cs typeface="Helvetica Neue"/>
               </a:rPr>
-              <a:t>frame set my_protocol reviewed true</a:t>
+              <a:t>frame --state demo-frames.json set my_protocol reviewed true</a:t>
             </a:r>
           </a:p>
           <a:p xmlns:a="http://schemas.openxmlformats.org/drawingml/2006/main">
@@ -8623,7 +8861,7 @@
                 <a:ea typeface="Helvetica Neue"/>
                 <a:cs typeface="Helvetica Neue"/>
               </a:rPr>
-              <a:t>frame find reviewed true</a:t>
+              <a:t>frame --state demo-frames.json find reviewed true</a:t>
             </a:r>
           </a:p>
           <a:p xmlns:a="http://schemas.openxmlformats.org/drawingml/2006/main">
@@ -8647,7 +8885,7 @@
                 <a:ea typeface="Helvetica Neue"/>
                 <a:cs typeface="Helvetica Neue"/>
               </a:rPr>
-              <a:t>frame show my_protocol</a:t>
+              <a:t>frame --state demo-frames.json show my_protocol</a:t>
             </a:r>
           </a:p>
         </p:txBody>
@@ -8705,7 +8943,7 @@
                 <a:ea typeface="Helvetica Neue"/>
                 <a:cs typeface="Helvetica Neue"/>
               </a:rPr>
-              <a:t>Изменения сохраняются атомарно и загружаются помощником.</a:t>
+              <a:t>Перед командами: python3 -m project_assistant</a:t>
             </a:r>
           </a:p>
           <a:p xmlns:a="http://schemas.openxmlformats.org/drawingml/2006/main">
@@ -8729,7 +8967,7 @@
                 <a:ea typeface="Helvetica Neue"/>
                 <a:cs typeface="Helvetica Neue"/>
               </a:rPr>
-              <a:t>Поиск учитывает унаследованные свойства.</a:t>
+              <a:t>Поиск учитывает наследование; JSON сохраняется между запусками.</a:t>
             </a:r>
           </a:p>
         </p:txBody>
@@ -9422,7 +9660,13 @@
       </p:sp>
       <p:graphicFrame>
         <p:nvGraphicFramePr>
-          <p:cNvPr id="13" name=""/>
+          <p:cNvPr id="13" name="">
+            <a:extLst xmlns:a="http://schemas.openxmlformats.org/drawingml/2006/main">
+              <a:ext uri="{FF2B5EF4-FFF2-40B4-BE49-F238E27FC236}">
+                <a16:creationId xmlns:a16="http://schemas.microsoft.com/office/drawing/2014/main" id="{A518A44D-49DC-424C-B510-D8EEE5494657}"/>
+              </a:ext>
+            </a:extLst>
+          </p:cNvPr>
           <p:cNvGraphicFramePr/>
           <p:nvPr/>
         </p:nvGraphicFramePr>

</xml_diff>